<commit_message>
Compress & Repair functionaly added
</commit_message>
<xml_diff>
--- a/python-engine/tests/outputs/pdf2ppt.pptx
+++ b/python-engine/tests/outputs/pdf2ppt.pptx
@@ -8,7 +8,7 @@
     <p:sldId id="256" r:id="rId7"/>
     <p:sldId id="257" r:id="rId8"/>
   </p:sldIdLst>
-  <p:sldSz cx="9144000" cy="6858000" type="screen4x3"/>
+  <p:sldSz cx="12188952" cy="6858000" type="screen4x3"/>
   <p:notesSz cx="6858000" cy="9144000"/>
   <p:defaultTextStyle>
     <a:defPPr>
@@ -3098,7 +3098,7 @@
         <p:spPr>
           <a:xfrm>
             <a:off x="685800" y="685800"/>
-            <a:ext cx="7772400" cy="5486400"/>
+            <a:ext cx="10817352" cy="5486400"/>
           </a:xfrm>
           <a:prstGeom prst="rect">
             <a:avLst/>
@@ -3150,7 +3150,7 @@
         <p:spPr>
           <a:xfrm>
             <a:off x="685800" y="685800"/>
-            <a:ext cx="7772400" cy="5486400"/>
+            <a:ext cx="10817352" cy="5486400"/>
           </a:xfrm>
           <a:prstGeom prst="rect">
             <a:avLst/>

</xml_diff>